<commit_message>
Add confirmed Power BI link to presentation and PowerPoint
</commit_message>
<xml_diff>
--- a/coo-technology-update-2026-10-14/downloads/coo-technology-update-2026-10-14.pptx
+++ b/coo-technology-update-2026-10-14/downloads/coo-technology-update-2026-10-14.pptx
@@ -3633,7 +3633,9 @@
       </p:sp>
       <p:sp>
         <p:nvSpPr>
-          <p:cNvPr id="12" name="Shape 8"/>
+          <p:cNvPr id="12" name="Shape 8">
+            <a:hlinkClick r:id="rIdPowerBiReport"/>
+          </p:cNvPr>
           <p:cNvSpPr/>
           <p:nvPr/>
         </p:nvSpPr>
@@ -3653,7 +3655,9 @@
       </p:sp>
       <p:sp>
         <p:nvSpPr>
-          <p:cNvPr id="13" name="Text 9"/>
+          <p:cNvPr id="13" name="Text 9">
+            <a:hlinkClick r:id="rIdPowerBiReport"/>
+          </p:cNvPr>
           <p:cNvSpPr/>
           <p:nvPr/>
         </p:nvSpPr>

</xml_diff>